<commit_message>
fix(course): make rewritten facts true and consistent (CLI minimum, Haiku pins, auto mode, cost factors)
- prerequisites.md: stop claiming 2.1.197 covers today's generations; minimum
  CLIs per changelog.md:1583 (Fable 5.1, 2.1.257), :483 (Opus 5.5, 2.1.280),
  :14 (Sonnet 5.5, 2.1.284); pinned as version-pinned.
- Haiku 200K context number pinned (cockpit :1550/:1962, glossary, block-1),
  values match the canon (Haiku 200K, others 1M).
- auto mode: all plans, supported model (not Haiku), admin can disable
  (permission-modes.md:296-299) in quick-reference, glossary, faq.
- cost factors aligned with canon prices (Opus 2x Sonnet, Haiku 0.5x Sonnet,
  25% of Opus, pipeline ~1.75x) in block-3, cockpit; pricing pointer now canon.
- exercises: haiku alias without --effort (Haiku has no effort setting).
- deck: slide 6 title de-versioned in build_deck.py; regenerated only
  claude-code-workshop-4session.pptx.

Co-Authored-By: Claude Opus 5.5 (1M context) <noreply@anthropic.com>
</commit_message>
<xml_diff>
--- a/claude-code-workshop-4session.pptx
+++ b/claude-code-workshop-4session.pptx
@@ -3853,7 +3853,7 @@
                 </a:solidFill>
                 <a:latin typeface="Segoe UI"/>
               </a:rPr>
-              <a:t>cloud-code-workshop-ui.html — 65 LEs, Slides, Übungen, Quiz, Fortschritt.</a:t>
+              <a:t>claude-code-workshop-ui.html — 65 LEs, Slides, Übungen, Quiz, Fortschritt.</a:t>
             </a:r>
           </a:p>
         </p:txBody>
@@ -8822,7 +8822,7 @@
                 </a:solidFill>
                 <a:latin typeface="Segoe UI"/>
               </a:rPr>
-              <a:t>Interaktives Lern-Cockpit (cloud-code-workshop-ui.html) + Mentor-Agent begleiten das Selbststudium.</a:t>
+              <a:t>Interaktives Lern-Cockpit (claude-code-workshop-ui.html) + Mentor-Agent begleiten das Selbststudium.</a:t>
             </a:r>
           </a:p>
         </p:txBody>
@@ -9606,7 +9606,7 @@
                 </a:solidFill>
                 <a:latin typeface="Segoe UI"/>
               </a:rPr>
-              <a:t>Modellwahl &amp; Effort (Opus 4.8 / Sonnet 5 / Haiku / Fable 5)</a:t>
+              <a:t>Modellwahl &amp; Effort (Tiers: Opus / Sonnet / Haiku / Fable)</a:t>
             </a:r>
           </a:p>
         </p:txBody>

</xml_diff>